<commit_message>
Update the reported test count to 117 across the deck and docs
The schema-collision fix added three regression tests. The progress deck,
README and demo guide still quoted 114.
</commit_message>
<xml_diff>
--- a/docs/reports/WEEK4-PROGRESS-REPORT.pptx
+++ b/docs/reports/WEEK4-PROGRESS-REPORT.pptx
@@ -3428,7 +3428,7 @@
                 </a:solidFill>
                 <a:latin typeface="Arial"/>
               </a:rPr>
-              <a:t>Phase 1 complete  ·  Phase 2 in progress  ·  114 automated tests passing</a:t>
+              <a:t>Phase 1 complete  ·  Phase 2 in progress  ·  117 automated tests passing</a:t>
             </a:r>
           </a:p>
         </p:txBody>
@@ -6548,7 +6548,7 @@
                           </a:solidFill>
                           <a:latin typeface="Arial"/>
                         </a:rPr>
-                        <a:t>114</a:t>
+                        <a:t>117</a:t>
                       </a:r>
                     </a:p>
                   </a:txBody>
@@ -7760,7 +7760,7 @@
                 </a:solidFill>
                 <a:latin typeface="Arial"/>
               </a:rPr>
-              <a:t>114 automated tests, no API key required, zero cost per run.</a:t>
+              <a:t>117 automated tests, green on Python 3.11, 3.12 and 3.13. No API key required, zero cost per run.</a:t>
             </a:r>
           </a:p>
         </p:txBody>
@@ -10044,7 +10044,7 @@
                 </a:solidFill>
                 <a:latin typeface="Arial"/>
               </a:rPr>
-              <a:t>Runs the full suite: 114 tests in about eight seconds.</a:t>
+              <a:t>Runs the full suite: 117 tests in about four seconds.</a:t>
             </a:r>
           </a:p>
         </p:txBody>

</xml_diff>